<commit_message>
Deploying to gh-pages from @ tamanh-oxford/capacity-development@0b2f1f6769a3f1698f99471907a8b4a15734515f 🚀
</commit_message>
<xml_diff>
--- a/data-frameworks/course-outline.pptx
+++ b/data-frameworks/course-outline.pptx
@@ -3298,13 +3298,6 @@
             <a:r>
               <a:rPr/>
               <a:t>Global landscape of available technologies for data</a:t>
-            </a:r>
-          </a:p>
-          <a:p>
-            <a:pPr lvl="0"/>
-            <a:r>
-              <a:rPr/>
-              <a:t>Data Exercise: Working with Excel</a:t>
             </a:r>
           </a:p>
           <a:p>

</xml_diff>